<commit_message>
v3: poprawiony pin lotniska na TERMINAL (63.9950,-22.6239) + nowy kadr
</commit_message>
<xml_diff>
--- a/MCG_zostaw-auto_MAPA-OSM_EDYTOWALNY.pptx
+++ b/MCG_zostaw-auto_MAPA-OSM_EDYTOWALNY.pptx
@@ -3120,8 +3120,8 @@
         </p:nvCxnSpPr>
         <p:spPr>
           <a:xfrm flipH="1" flipV="1">
-            <a:off x="7562947" y="6363380"/>
-            <a:ext cx="438053" cy="304120"/>
+            <a:off x="7919454" y="6917239"/>
+            <a:ext cx="462546" cy="321761"/>
           </a:xfrm>
           <a:prstGeom prst="line">
             <a:avLst/>
@@ -3156,8 +3156,8 @@
         </p:nvCxnSpPr>
         <p:spPr>
           <a:xfrm flipH="1" flipV="1">
-            <a:off x="7119645" y="6076950"/>
-            <a:ext cx="443302" cy="286430"/>
+            <a:off x="7457103" y="6605101"/>
+            <a:ext cx="462351" cy="312138"/>
           </a:xfrm>
           <a:prstGeom prst="line">
             <a:avLst/>
@@ -3191,8 +3191,8 @@
         </p:nvCxnSpPr>
         <p:spPr>
           <a:xfrm flipH="1" flipV="1">
-            <a:off x="6671096" y="5808208"/>
-            <a:ext cx="448549" cy="268742"/>
+            <a:off x="6994946" y="6302585"/>
+            <a:ext cx="462157" cy="302516"/>
           </a:xfrm>
           <a:prstGeom prst="line">
             <a:avLst/>
@@ -3227,8 +3227,8 @@
         </p:nvCxnSpPr>
         <p:spPr>
           <a:xfrm flipH="1" flipV="1">
-            <a:off x="6217297" y="5557157"/>
-            <a:ext cx="453799" cy="251051"/>
+            <a:off x="6532983" y="6009691"/>
+            <a:ext cx="461963" cy="292894"/>
           </a:xfrm>
           <a:prstGeom prst="line">
             <a:avLst/>
@@ -3262,8 +3262,8 @@
         </p:nvCxnSpPr>
         <p:spPr>
           <a:xfrm flipH="1" flipV="1">
-            <a:off x="5758251" y="5323794"/>
-            <a:ext cx="459046" cy="233363"/>
+            <a:off x="6071215" y="5726420"/>
+            <a:ext cx="461768" cy="283271"/>
           </a:xfrm>
           <a:prstGeom prst="line">
             <a:avLst/>
@@ -3298,8 +3298,8 @@
         </p:nvCxnSpPr>
         <p:spPr>
           <a:xfrm flipH="1" flipV="1">
-            <a:off x="5293956" y="5108121"/>
-            <a:ext cx="464295" cy="215673"/>
+            <a:off x="5609641" y="5452770"/>
+            <a:ext cx="461574" cy="273650"/>
           </a:xfrm>
           <a:prstGeom prst="line">
             <a:avLst/>
@@ -3333,8 +3333,8 @@
         </p:nvCxnSpPr>
         <p:spPr>
           <a:xfrm flipH="1" flipV="1">
-            <a:off x="4824412" y="4910137"/>
-            <a:ext cx="469544" cy="197984"/>
+            <a:off x="5148262" y="5188743"/>
+            <a:ext cx="461379" cy="264027"/>
           </a:xfrm>
           <a:prstGeom prst="line">
             <a:avLst/>
@@ -3369,8 +3369,8 @@
         </p:nvCxnSpPr>
         <p:spPr>
           <a:xfrm flipH="1" flipV="1">
-            <a:off x="4349620" y="4729842"/>
-            <a:ext cx="474792" cy="180295"/>
+            <a:off x="4687077" y="4934338"/>
+            <a:ext cx="461185" cy="254405"/>
           </a:xfrm>
           <a:prstGeom prst="line">
             <a:avLst/>
@@ -3404,8 +3404,8 @@
         </p:nvCxnSpPr>
         <p:spPr>
           <a:xfrm flipH="1" flipV="1">
-            <a:off x="3869579" y="4567237"/>
-            <a:ext cx="480041" cy="162605"/>
+            <a:off x="4226086" y="4689555"/>
+            <a:ext cx="460991" cy="244783"/>
           </a:xfrm>
           <a:prstGeom prst="line">
             <a:avLst/>
@@ -3440,8 +3440,8 @@
         </p:nvCxnSpPr>
         <p:spPr>
           <a:xfrm flipH="1" flipV="1">
-            <a:off x="3384290" y="4422321"/>
-            <a:ext cx="485289" cy="144916"/>
+            <a:off x="3765290" y="4454395"/>
+            <a:ext cx="460796" cy="235160"/>
           </a:xfrm>
           <a:prstGeom prst="line">
             <a:avLst/>
@@ -3475,8 +3475,8 @@
         </p:nvCxnSpPr>
         <p:spPr>
           <a:xfrm flipH="1" flipV="1">
-            <a:off x="2893753" y="4295094"/>
-            <a:ext cx="490537" cy="127227"/>
+            <a:off x="3304689" y="4228857"/>
+            <a:ext cx="460601" cy="225538"/>
           </a:xfrm>
           <a:prstGeom prst="line">
             <a:avLst/>
@@ -3511,8 +3511,8 @@
         </p:nvCxnSpPr>
         <p:spPr>
           <a:xfrm flipH="1" flipV="1">
-            <a:off x="2397967" y="4185557"/>
-            <a:ext cx="495786" cy="109537"/>
+            <a:off x="2844281" y="4012940"/>
+            <a:ext cx="460408" cy="215917"/>
           </a:xfrm>
           <a:prstGeom prst="line">
             <a:avLst/>
@@ -3546,8 +3546,8 @@
         </p:nvCxnSpPr>
         <p:spPr>
           <a:xfrm flipH="1" flipV="1">
-            <a:off x="1896932" y="4093708"/>
-            <a:ext cx="501035" cy="91849"/>
+            <a:off x="2384068" y="3806646"/>
+            <a:ext cx="460213" cy="206294"/>
           </a:xfrm>
           <a:prstGeom prst="line">
             <a:avLst/>
@@ -3582,8 +3582,8 @@
         </p:nvCxnSpPr>
         <p:spPr>
           <a:xfrm flipH="1" flipV="1">
-            <a:off x="1390650" y="4019550"/>
-            <a:ext cx="506282" cy="74158"/>
+            <a:off x="1924050" y="3609975"/>
+            <a:ext cx="460018" cy="196671"/>
           </a:xfrm>
           <a:prstGeom prst="line">
             <a:avLst/>
@@ -3617,7 +3617,7 @@
         </p:nvSpPr>
         <p:spPr>
           <a:xfrm>
-            <a:off x="7685532" y="6886575"/>
+            <a:off x="8066532" y="7458075"/>
             <a:ext cx="630936" cy="902589"/>
           </a:xfrm>
           <a:custGeom>
@@ -3679,7 +3679,7 @@
         </p:nvSpPr>
         <p:spPr>
           <a:xfrm>
-            <a:off x="7562850" y="6229350"/>
+            <a:off x="7943850" y="6800850"/>
             <a:ext cx="876300" cy="876300"/>
           </a:xfrm>
           <a:prstGeom prst="ellipse">
@@ -3721,7 +3721,7 @@
         </p:nvSpPr>
         <p:spPr>
           <a:xfrm>
-            <a:off x="7772400" y="6464808"/>
+            <a:off x="8153400" y="7036308"/>
             <a:ext cx="457200" cy="329184"/>
           </a:xfrm>
           <a:custGeom>
@@ -3795,7 +3795,7 @@
         </p:nvSpPr>
         <p:spPr>
           <a:xfrm>
-            <a:off x="7772400" y="6739128"/>
+            <a:off x="8153400" y="7310628"/>
             <a:ext cx="457200" cy="54864"/>
           </a:xfrm>
           <a:prstGeom prst="rect">
@@ -3837,7 +3837,7 @@
         </p:nvSpPr>
         <p:spPr>
           <a:xfrm>
-            <a:off x="1116330" y="4210050"/>
+            <a:off x="1649730" y="3800475"/>
             <a:ext cx="548640" cy="784860"/>
           </a:xfrm>
           <a:custGeom>
@@ -3899,7 +3899,7 @@
         </p:nvSpPr>
         <p:spPr>
           <a:xfrm>
-            <a:off x="1009650" y="3638550"/>
+            <a:off x="1543050" y="3228975"/>
             <a:ext cx="762000" cy="762000"/>
           </a:xfrm>
           <a:prstGeom prst="ellipse">
@@ -3941,7 +3941,7 @@
         </p:nvSpPr>
         <p:spPr>
           <a:xfrm>
-            <a:off x="1191577" y="3771900"/>
+            <a:off x="1724977" y="3362325"/>
             <a:ext cx="398145" cy="429577"/>
           </a:xfrm>
           <a:custGeom>
@@ -4042,7 +4042,7 @@
         </p:nvSpPr>
         <p:spPr>
           <a:xfrm>
-            <a:off x="400050" y="5086350"/>
+            <a:off x="933450" y="4676775"/>
             <a:ext cx="1981200" cy="495300"/>
           </a:xfrm>
           <a:prstGeom prst="roundRect">
@@ -4086,7 +4086,7 @@
         </p:nvSpPr>
         <p:spPr>
           <a:xfrm>
-            <a:off x="400050" y="5086350"/>
+            <a:off x="933450" y="4676775"/>
             <a:ext cx="1981200" cy="495300"/>
           </a:xfrm>
           <a:prstGeom prst="rect">
@@ -4121,7 +4121,7 @@
         </p:nvSpPr>
         <p:spPr>
           <a:xfrm>
-            <a:off x="4857750" y="6362700"/>
+            <a:off x="5238750" y="6934200"/>
             <a:ext cx="2590800" cy="609600"/>
           </a:xfrm>
           <a:prstGeom prst="roundRect">
@@ -4165,7 +4165,7 @@
         </p:nvSpPr>
         <p:spPr>
           <a:xfrm>
-            <a:off x="4857750" y="6362700"/>
+            <a:off x="5238750" y="6934200"/>
             <a:ext cx="2590800" cy="609600"/>
           </a:xfrm>
           <a:prstGeom prst="rect">

</xml_diff>

<commit_message>
v4: pin na wspolrzednych wizytowki Google (cross-check z OSM: 37 m)
</commit_message>
<xml_diff>
--- a/MCG_zostaw-auto_MAPA-OSM_EDYTOWALNY.pptx
+++ b/MCG_zostaw-auto_MAPA-OSM_EDYTOWALNY.pptx
@@ -3120,8 +3120,8 @@
         </p:nvCxnSpPr>
         <p:spPr>
           <a:xfrm flipH="1" flipV="1">
-            <a:off x="7919454" y="6917239"/>
-            <a:ext cx="462546" cy="321761"/>
+            <a:off x="7878389" y="6909026"/>
+            <a:ext cx="455986" cy="320449"/>
           </a:xfrm>
           <a:prstGeom prst="line">
             <a:avLst/>
@@ -3156,8 +3156,8 @@
         </p:nvCxnSpPr>
         <p:spPr>
           <a:xfrm flipH="1" flipV="1">
-            <a:off x="7457103" y="6605101"/>
-            <a:ext cx="462351" cy="312138"/>
+            <a:off x="7422113" y="6598103"/>
+            <a:ext cx="456276" cy="310923"/>
           </a:xfrm>
           <a:prstGeom prst="line">
             <a:avLst/>
@@ -3191,8 +3191,8 @@
         </p:nvCxnSpPr>
         <p:spPr>
           <a:xfrm flipH="1" flipV="1">
-            <a:off x="6994946" y="6302585"/>
-            <a:ext cx="462157" cy="302516"/>
+            <a:off x="6965545" y="6296705"/>
+            <a:ext cx="456568" cy="301398"/>
           </a:xfrm>
           <a:prstGeom prst="line">
             <a:avLst/>
@@ -3227,8 +3227,8 @@
         </p:nvCxnSpPr>
         <p:spPr>
           <a:xfrm flipH="1" flipV="1">
-            <a:off x="6532983" y="6009691"/>
-            <a:ext cx="461963" cy="292894"/>
+            <a:off x="6508685" y="6004832"/>
+            <a:ext cx="456860" cy="291873"/>
           </a:xfrm>
           <a:prstGeom prst="line">
             <a:avLst/>
@@ -3262,8 +3262,8 @@
         </p:nvCxnSpPr>
         <p:spPr>
           <a:xfrm flipH="1" flipV="1">
-            <a:off x="6071215" y="5726420"/>
-            <a:ext cx="461768" cy="283271"/>
+            <a:off x="6051533" y="5722483"/>
+            <a:ext cx="457152" cy="282349"/>
           </a:xfrm>
           <a:prstGeom prst="line">
             <a:avLst/>
@@ -3298,8 +3298,8 @@
         </p:nvCxnSpPr>
         <p:spPr>
           <a:xfrm flipH="1" flipV="1">
-            <a:off x="5609641" y="5452770"/>
-            <a:ext cx="461574" cy="273650"/>
+            <a:off x="5594090" y="5449660"/>
+            <a:ext cx="457443" cy="272823"/>
           </a:xfrm>
           <a:prstGeom prst="line">
             <a:avLst/>
@@ -3333,8 +3333,8 @@
         </p:nvCxnSpPr>
         <p:spPr>
           <a:xfrm flipH="1" flipV="1">
-            <a:off x="5148262" y="5188743"/>
-            <a:ext cx="461379" cy="264027"/>
+            <a:off x="5136356" y="5186362"/>
+            <a:ext cx="457734" cy="263298"/>
           </a:xfrm>
           <a:prstGeom prst="line">
             <a:avLst/>
@@ -3369,8 +3369,8 @@
         </p:nvCxnSpPr>
         <p:spPr>
           <a:xfrm flipH="1" flipV="1">
-            <a:off x="4687077" y="4934338"/>
-            <a:ext cx="461185" cy="254405"/>
+            <a:off x="4678330" y="4932589"/>
+            <a:ext cx="458026" cy="253773"/>
           </a:xfrm>
           <a:prstGeom prst="line">
             <a:avLst/>
@@ -3404,8 +3404,8 @@
         </p:nvCxnSpPr>
         <p:spPr>
           <a:xfrm flipH="1" flipV="1">
-            <a:off x="4226086" y="4689555"/>
-            <a:ext cx="460991" cy="244783"/>
+            <a:off x="4220012" y="4688341"/>
+            <a:ext cx="458318" cy="244248"/>
           </a:xfrm>
           <a:prstGeom prst="line">
             <a:avLst/>
@@ -3440,8 +3440,8 @@
         </p:nvCxnSpPr>
         <p:spPr>
           <a:xfrm flipH="1" flipV="1">
-            <a:off x="3765290" y="4454395"/>
-            <a:ext cx="460796" cy="235160"/>
+            <a:off x="3761403" y="4453617"/>
+            <a:ext cx="458609" cy="234724"/>
           </a:xfrm>
           <a:prstGeom prst="line">
             <a:avLst/>
@@ -3475,8 +3475,8 @@
         </p:nvCxnSpPr>
         <p:spPr>
           <a:xfrm flipH="1" flipV="1">
-            <a:off x="3304689" y="4228857"/>
-            <a:ext cx="460601" cy="225538"/>
+            <a:off x="3302502" y="4228419"/>
+            <a:ext cx="458901" cy="225198"/>
           </a:xfrm>
           <a:prstGeom prst="line">
             <a:avLst/>
@@ -3511,8 +3511,8 @@
         </p:nvCxnSpPr>
         <p:spPr>
           <a:xfrm flipH="1" flipV="1">
-            <a:off x="2844281" y="4012940"/>
-            <a:ext cx="460408" cy="215917"/>
+            <a:off x="2843309" y="4012746"/>
+            <a:ext cx="459193" cy="215673"/>
           </a:xfrm>
           <a:prstGeom prst="line">
             <a:avLst/>
@@ -3546,8 +3546,8 @@
         </p:nvCxnSpPr>
         <p:spPr>
           <a:xfrm flipH="1" flipV="1">
-            <a:off x="2384068" y="3806646"/>
-            <a:ext cx="460213" cy="206294"/>
+            <a:off x="2383825" y="3806598"/>
+            <a:ext cx="459484" cy="206148"/>
           </a:xfrm>
           <a:prstGeom prst="line">
             <a:avLst/>
@@ -3583,7 +3583,7 @@
         <p:spPr>
           <a:xfrm flipH="1" flipV="1">
             <a:off x="1924050" y="3609975"/>
-            <a:ext cx="460018" cy="196671"/>
+            <a:ext cx="459775" cy="196623"/>
           </a:xfrm>
           <a:prstGeom prst="line">
             <a:avLst/>
@@ -3617,7 +3617,7 @@
         </p:nvSpPr>
         <p:spPr>
           <a:xfrm>
-            <a:off x="8066532" y="7458075"/>
+            <a:off x="8018907" y="7448550"/>
             <a:ext cx="630936" cy="902589"/>
           </a:xfrm>
           <a:custGeom>
@@ -3679,7 +3679,7 @@
         </p:nvSpPr>
         <p:spPr>
           <a:xfrm>
-            <a:off x="7943850" y="6800850"/>
+            <a:off x="7896225" y="6791325"/>
             <a:ext cx="876300" cy="876300"/>
           </a:xfrm>
           <a:prstGeom prst="ellipse">
@@ -3721,7 +3721,7 @@
         </p:nvSpPr>
         <p:spPr>
           <a:xfrm>
-            <a:off x="8153400" y="7036308"/>
+            <a:off x="8105775" y="7026783"/>
             <a:ext cx="457200" cy="329184"/>
           </a:xfrm>
           <a:custGeom>
@@ -3795,7 +3795,7 @@
         </p:nvSpPr>
         <p:spPr>
           <a:xfrm>
-            <a:off x="8153400" y="7310628"/>
+            <a:off x="8105775" y="7301103"/>
             <a:ext cx="457200" cy="54864"/>
           </a:xfrm>
           <a:prstGeom prst="rect">
@@ -4121,7 +4121,7 @@
         </p:nvSpPr>
         <p:spPr>
           <a:xfrm>
-            <a:off x="5238750" y="6934200"/>
+            <a:off x="5191125" y="6924675"/>
             <a:ext cx="2590800" cy="609600"/>
           </a:xfrm>
           <a:prstGeom prst="roundRect">
@@ -4165,7 +4165,7 @@
         </p:nvSpPr>
         <p:spPr>
           <a:xfrm>
-            <a:off x="5238750" y="6934200"/>
+            <a:off x="5191125" y="6924675"/>
             <a:ext cx="2590800" cy="609600"/>
           </a:xfrm>
           <a:prstGeom prst="rect">

</xml_diff>